<commit_message>
Use Tesorio distribution for the Tesorio slide donut
Replace the invoices-by-portal bar on the Tesorio slide with a resolution
distribution donut built from Tesorio Tasks data (204 completed: 66.7% same day,
12.7% 1-2d, 18.1% 2-4d, 1.0% 4-7d, 1.5% >7d), so the percentages reconcile with
the slide's own numbers.

Co-Authored-By: Claude Opus 4.8 <noreply@anthropic.com>
Claude-Session: https://claude.ai/code/session_01Nn9QKEstPX9eZ4ngSPWHBW
</commit_message>
<xml_diff>
--- a/Portal_Metrics_Monthly_Sep-26.pptx
+++ b/Portal_Metrics_Monthly_Sep-26.pptx
@@ -479,7 +479,7 @@
           <a:lstStyle/>
           <a:p>
             <a:pPr>
-              <a:defRPr sz="1200" b="0" i="0" u="none" strike="noStrike">
+              <a:defRPr sz="1300" b="0" i="0" u="none" strike="noStrike">
                 <a:solidFill>
                   <a:srgbClr val="158158"/>
                 </a:solidFill>
@@ -487,13 +487,13 @@
               </a:defRPr>
             </a:pPr>
             <a:r>
-              <a:rPr sz="1200" b="0" i="0" u="none" strike="noStrike">
+              <a:rPr sz="1300" b="0" i="0" u="none" strike="noStrike">
                 <a:solidFill>
                   <a:srgbClr val="158158"/>
                 </a:solidFill>
                 <a:latin typeface="Calibri"/>
               </a:rPr>
-              <a:t>Invoices by portal (platforms we use most)</a:t>
+              <a:t>Resolution distribution (%)</a:t>
             </a:r>
           </a:p>
         </c:rich>
@@ -504,10 +504,8 @@
     <c:autoTitleDeleted val="0"/>
     <c:plotArea>
       <c:layout/>
-      <c:barChart>
-        <c:barDir val="bar"/>
-        <c:grouping val="clustered"/>
-        <c:varyColors val="0"/>
+      <c:doughnutChart>
+        <c:varyColors val="1"/>
         <c:ser>
           <c:idx val="0"/>
           <c:order val="0"/>
@@ -517,208 +515,273 @@
               <c:strCache>
                 <c:ptCount val="1"/>
                 <c:pt idx="0">
-                  <c:v>Invoices</c:v>
+                  <c:v>Distribution</c:v>
                 </c:pt>
               </c:strCache>
             </c:strRef>
           </c:tx>
           <c:spPr>
             <a:solidFill>
-              <a:srgbClr val="158158"/>
+              <a:schemeClr val="accent1"/>
             </a:solidFill>
+            <a:ln w="9525" cap="flat">
+              <a:solidFill>
+                <a:srgbClr val="F9F9F9"/>
+              </a:solidFill>
+              <a:prstDash val="solid"/>
+              <a:round/>
+            </a:ln>
             <a:effectLst/>
           </c:spPr>
-          <c:invertIfNegative val="0"/>
+          <c:dPt>
+            <c:idx val="0"/>
+            <c:bubble3D val="0"/>
+            <c:spPr>
+              <a:solidFill>
+                <a:srgbClr val="50B432"/>
+              </a:solidFill>
+              <a:effectLst/>
+            </c:spPr>
+          </c:dPt>
+          <c:dPt>
+            <c:idx val="1"/>
+            <c:bubble3D val="0"/>
+            <c:spPr>
+              <a:solidFill>
+                <a:srgbClr val="53B5E0"/>
+              </a:solidFill>
+              <a:effectLst/>
+            </c:spPr>
+          </c:dPt>
+          <c:dPt>
+            <c:idx val="2"/>
+            <c:bubble3D val="0"/>
+            <c:spPr>
+              <a:solidFill>
+                <a:srgbClr val="4292E1"/>
+              </a:solidFill>
+              <a:effectLst/>
+            </c:spPr>
+          </c:dPt>
+          <c:dPt>
+            <c:idx val="3"/>
+            <c:bubble3D val="0"/>
+            <c:spPr>
+              <a:solidFill>
+                <a:srgbClr val="ED8B1B"/>
+              </a:solidFill>
+              <a:effectLst/>
+            </c:spPr>
+          </c:dPt>
+          <c:dPt>
+            <c:idx val="4"/>
+            <c:bubble3D val="0"/>
+            <c:spPr>
+              <a:solidFill>
+                <a:srgbClr val="4A2ADB"/>
+              </a:solidFill>
+              <a:effectLst/>
+            </c:spPr>
+          </c:dPt>
           <c:dLbls>
-            <c:numFmt formatCode="#,##0" sourceLinked="0"/>
+            <c:dLbl>
+              <c:idx val="0"/>
+              <c:numFmt formatCode="0%" sourceLinked="0"/>
+              <c:spPr/>
+              <c:txPr>
+                <a:bodyPr/>
+                <a:lstStyle/>
+                <a:p>
+                  <a:pPr>
+                    <a:defRPr sz="900" b="0" i="0" u="none" strike="noStrike">
+                      <a:solidFill>
+                        <a:srgbClr val="FFFFFF"/>
+                      </a:solidFill>
+                      <a:latin typeface="Calibri"/>
+                    </a:defRPr>
+                  </a:pPr>
+                </a:p>
+              </c:txPr>
+              <c:showLegendKey val="0"/>
+              <c:showVal val="0"/>
+              <c:showCatName val="0"/>
+              <c:showSerName val="0"/>
+              <c:showPercent val="1"/>
+              <c:showBubbleSize val="0"/>
+            </c:dLbl>
+            <c:dLbl>
+              <c:idx val="1"/>
+              <c:numFmt formatCode="0%" sourceLinked="0"/>
+              <c:spPr/>
+              <c:txPr>
+                <a:bodyPr/>
+                <a:lstStyle/>
+                <a:p>
+                  <a:pPr>
+                    <a:defRPr sz="900" b="0" i="0" u="none" strike="noStrike">
+                      <a:solidFill>
+                        <a:srgbClr val="FFFFFF"/>
+                      </a:solidFill>
+                      <a:latin typeface="Calibri"/>
+                    </a:defRPr>
+                  </a:pPr>
+                </a:p>
+              </c:txPr>
+              <c:showLegendKey val="0"/>
+              <c:showVal val="0"/>
+              <c:showCatName val="0"/>
+              <c:showSerName val="0"/>
+              <c:showPercent val="1"/>
+              <c:showBubbleSize val="0"/>
+            </c:dLbl>
+            <c:dLbl>
+              <c:idx val="2"/>
+              <c:numFmt formatCode="0%" sourceLinked="0"/>
+              <c:spPr/>
+              <c:txPr>
+                <a:bodyPr/>
+                <a:lstStyle/>
+                <a:p>
+                  <a:pPr>
+                    <a:defRPr sz="900" b="0" i="0" u="none" strike="noStrike">
+                      <a:solidFill>
+                        <a:srgbClr val="FFFFFF"/>
+                      </a:solidFill>
+                      <a:latin typeface="Calibri"/>
+                    </a:defRPr>
+                  </a:pPr>
+                </a:p>
+              </c:txPr>
+              <c:showLegendKey val="0"/>
+              <c:showVal val="0"/>
+              <c:showCatName val="0"/>
+              <c:showSerName val="0"/>
+              <c:showPercent val="1"/>
+              <c:showBubbleSize val="0"/>
+            </c:dLbl>
+            <c:dLbl>
+              <c:idx val="3"/>
+              <c:numFmt formatCode="0%" sourceLinked="0"/>
+              <c:spPr/>
+              <c:txPr>
+                <a:bodyPr/>
+                <a:lstStyle/>
+                <a:p>
+                  <a:pPr>
+                    <a:defRPr sz="900" b="0" i="0" u="none" strike="noStrike">
+                      <a:solidFill>
+                        <a:srgbClr val="FFFFFF"/>
+                      </a:solidFill>
+                      <a:latin typeface="Calibri"/>
+                    </a:defRPr>
+                  </a:pPr>
+                </a:p>
+              </c:txPr>
+              <c:showLegendKey val="0"/>
+              <c:showVal val="0"/>
+              <c:showCatName val="0"/>
+              <c:showSerName val="0"/>
+              <c:showPercent val="1"/>
+              <c:showBubbleSize val="0"/>
+            </c:dLbl>
+            <c:dLbl>
+              <c:idx val="4"/>
+              <c:numFmt formatCode="0%" sourceLinked="0"/>
+              <c:spPr/>
+              <c:txPr>
+                <a:bodyPr/>
+                <a:lstStyle/>
+                <a:p>
+                  <a:pPr>
+                    <a:defRPr sz="900" b="0" i="0" u="none" strike="noStrike">
+                      <a:solidFill>
+                        <a:srgbClr val="FFFFFF"/>
+                      </a:solidFill>
+                      <a:latin typeface="Calibri"/>
+                    </a:defRPr>
+                  </a:pPr>
+                </a:p>
+              </c:txPr>
+              <c:showLegendKey val="0"/>
+              <c:showVal val="0"/>
+              <c:showCatName val="0"/>
+              <c:showSerName val="0"/>
+              <c:showPercent val="1"/>
+              <c:showBubbleSize val="0"/>
+            </c:dLbl>
+            <c:numFmt formatCode="0%" sourceLinked="0"/>
             <c:txPr>
               <a:bodyPr/>
               <a:lstStyle/>
               <a:p>
                 <a:pPr>
-                  <a:defRPr b="0" i="0" strike="noStrike" sz="1000" u="none">
+                  <a:defRPr sz="1800" b="0" i="0" u="none" strike="noStrike">
                     <a:solidFill>
-                      <a:srgbClr val="1F2A44"/>
+                      <a:srgbClr val="000000"/>
                     </a:solidFill>
-                    <a:latin typeface="Calibri"/>
+                    <a:latin typeface="Arial"/>
                   </a:defRPr>
                 </a:pPr>
               </a:p>
             </c:txPr>
             <c:showLegendKey val="0"/>
-            <c:showVal val="1"/>
-            <c:showCatName val="0"/>
+            <c:showVal val="0"/>
+            <c:showCatName val="1"/>
             <c:showSerName val="0"/>
-            <c:showPercent val="0"/>
+            <c:showPercent val="1"/>
             <c:showBubbleSize val="0"/>
             <c:showLeaderLines val="0"/>
           </c:dLbls>
           <c:cat>
-            <c:multiLvlStrRef>
-              <c:f>Sheet1!$A$2:$A$7</c:f>
-              <c:multiLvlStrCache>
-                <c:ptCount val="6"/>
-                <c:lvl>
-                  <c:pt idx="0">
-                    <c:v>Coupa</c:v>
-                  </c:pt>
-                  <c:pt idx="1">
-                    <c:v>Ariba</c:v>
-                  </c:pt>
-                  <c:pt idx="2">
-                    <c:v>Taulia</c:v>
-                  </c:pt>
-                  <c:pt idx="3">
-                    <c:v>URL</c:v>
-                  </c:pt>
-                  <c:pt idx="4">
-                    <c:v>Chorus Pro</c:v>
-                  </c:pt>
-                  <c:pt idx="5">
-                    <c:v>Oracle</c:v>
-                  </c:pt>
-                </c:lvl>
-              </c:multiLvlStrCache>
-            </c:multiLvlStrRef>
+            <c:strRef>
+              <c:f>Sheet1!$A$2:$A$6</c:f>
+              <c:strCache>
+                <c:ptCount val="5"/>
+                <c:pt idx="0">
+                  <c:v>Same day</c:v>
+                </c:pt>
+                <c:pt idx="1">
+                  <c:v>1-2 d</c:v>
+                </c:pt>
+                <c:pt idx="2">
+                  <c:v>2-4 d</c:v>
+                </c:pt>
+                <c:pt idx="3">
+                  <c:v>4-7 d</c:v>
+                </c:pt>
+                <c:pt idx="4">
+                  <c:v>&gt;7 d</c:v>
+                </c:pt>
+              </c:strCache>
+            </c:strRef>
           </c:cat>
           <c:val>
             <c:numRef>
-              <c:f>Sheet1!$B$2:$B$7</c:f>
+              <c:f>Sheet1!$B$2:$B$6</c:f>
               <c:numCache>
-                <c:formatCode>General</c:formatCode>
-                <c:ptCount val="6"/>
+                <c:ptCount val="5"/>
                 <c:pt idx="0">
-                  <c:v>28</c:v>
+                  <c:v>136</c:v>
                 </c:pt>
                 <c:pt idx="1">
-                  <c:v>18</c:v>
+                  <c:v>26</c:v>
                 </c:pt>
                 <c:pt idx="2">
-                  <c:v>9</c:v>
+                  <c:v>37</c:v>
                 </c:pt>
                 <c:pt idx="3">
-                  <c:v>6</c:v>
+                  <c:v>2</c:v>
                 </c:pt>
                 <c:pt idx="4">
-                  <c:v>5</c:v>
-                </c:pt>
-                <c:pt idx="5">
                   <c:v>3</c:v>
                 </c:pt>
               </c:numCache>
             </c:numRef>
           </c:val>
         </c:ser>
-        <c:dLbls>
-          <c:numFmt formatCode="#,##0" sourceLinked="0"/>
-          <c:txPr>
-            <a:bodyPr/>
-            <a:lstStyle/>
-            <a:p>
-              <a:pPr>
-                <a:defRPr b="0" i="0" strike="noStrike" sz="1000" u="none">
-                  <a:solidFill>
-                    <a:srgbClr val="1F2A44"/>
-                  </a:solidFill>
-                  <a:latin typeface="Calibri"/>
-                </a:defRPr>
-              </a:pPr>
-            </a:p>
-          </c:txPr>
-          <c:showLegendKey val="0"/>
-          <c:showVal val="1"/>
-          <c:showCatName val="0"/>
-          <c:showSerName val="0"/>
-          <c:showPercent val="0"/>
-          <c:showBubbleSize val="0"/>
-          <c:showLeaderLines val="0"/>
-        </c:dLbls>
-        <c:gapWidth val="150"/>
-        <c:overlap val="0"/>
-        <c:axId val="2094734554"/>
-        <c:axId val="2094734552"/>
-        <c:axId val="2094734556"/>
-      </c:barChart>
-      <c:catAx>
-        <c:axId val="2094734554"/>
-        <c:scaling>
-          <c:orientation val="minMax"/>
-        </c:scaling>
-        <c:delete val="0"/>
-        <c:axPos val="l"/>
-        <c:numFmt formatCode="General" sourceLinked="1"/>
-        <c:majorTickMark val="out"/>
-        <c:minorTickMark val="none"/>
-        <c:tickLblPos val="nextTo"/>
-        <c:spPr>
-          <a:ln w="12700" cap="flat">
-            <a:solidFill>
-              <a:srgbClr val="888888"/>
-            </a:solidFill>
-            <a:prstDash val="solid"/>
-            <a:round/>
-          </a:ln>
-        </c:spPr>
-        <c:txPr>
-          <a:bodyPr/>
-          <a:lstStyle/>
-          <a:p>
-            <a:pPr>
-              <a:defRPr sz="1000" b="0" i="0" u="none" strike="noStrike">
-                <a:solidFill>
-                  <a:srgbClr val="6B7B84"/>
-                </a:solidFill>
-                <a:latin typeface="Calibri"/>
-              </a:defRPr>
-            </a:pPr>
-            <a:endParaRPr lang="en-US"/>
-          </a:p>
-        </c:txPr>
-        <c:crossAx val="2094734552"/>
-        <c:crosses val="autoZero"/>
-        <c:auto val="1"/>
-        <c:lblAlgn val="ctr"/>
-        <c:noMultiLvlLbl val="1"/>
-      </c:catAx>
-      <c:valAx>
-        <c:axId val="2094734552"/>
-        <c:scaling>
-          <c:orientation val="minMax"/>
-        </c:scaling>
-        <c:delete val="1"/>
-        <c:axPos val="b"/>
-        <c:numFmt formatCode="General" sourceLinked="0"/>
-        <c:majorTickMark val="out"/>
-        <c:minorTickMark val="none"/>
-        <c:tickLblPos val="low"/>
-        <c:spPr>
-          <a:ln w="12700" cap="flat">
-            <a:solidFill>
-              <a:srgbClr val="888888"/>
-            </a:solidFill>
-            <a:prstDash val="solid"/>
-            <a:round/>
-          </a:ln>
-        </c:spPr>
-        <c:txPr>
-          <a:bodyPr/>
-          <a:lstStyle/>
-          <a:p>
-            <a:pPr>
-              <a:defRPr sz="1200" b="0" i="0" u="none" strike="noStrike">
-                <a:solidFill>
-                  <a:srgbClr val="000000"/>
-                </a:solidFill>
-                <a:latin typeface="Arial"/>
-              </a:defRPr>
-            </a:pPr>
-            <a:endParaRPr lang="en-US"/>
-          </a:p>
-        </c:txPr>
-        <c:crossAx val="2094734554"/>
-        <c:crosses val="autoZero"/>
-        <c:crossBetween val="between"/>
-      </c:valAx>
+        <c:firstSliceAng val="0"/>
+        <c:holeSize val="58"/>
+      </c:doughnutChart>
       <c:spPr>
         <a:noFill/>
         <a:ln>
@@ -727,6 +790,26 @@
         <a:effectLst/>
       </c:spPr>
     </c:plotArea>
+    <c:legend>
+      <c:legendPos val="r"/>
+      <c:overlay val="0"/>
+      <c:txPr>
+        <a:bodyPr/>
+        <a:lstStyle/>
+        <a:p>
+          <a:pPr>
+            <a:defRPr sz="1000">
+              <a:solidFill>
+                <a:srgbClr val="1F2A44"/>
+              </a:solidFill>
+              <a:latin typeface="Calibri"/>
+              <a:cs typeface="Calibri"/>
+            </a:defRPr>
+          </a:pPr>
+          <a:endParaRPr lang="en-US"/>
+        </a:p>
+      </c:txPr>
+    </c:legend>
     <c:plotVisOnly val="1"/>
     <c:dispBlanksAs val="span"/>
   </c:chart>

</xml_diff>